<commit_message>
No changes were provided to summarize.
</commit_message>
<xml_diff>
--- a/programing/Tuần 3/tuần 3.pptx
+++ b/programing/Tuần 3/tuần 3.pptx
@@ -6,6 +6,8 @@
   </p:sldMasterIdLst>
   <p:sldIdLst>
     <p:sldId id="256" r:id="rId2"/>
+    <p:sldId id="257" r:id="rId3"/>
+    <p:sldId id="258" r:id="rId4"/>
   </p:sldIdLst>
   <p:sldSz cx="12192000" cy="6858000"/>
   <p:notesSz cx="6858000" cy="9144000"/>
@@ -104,6 +106,11 @@
       </a:defRPr>
     </a:lvl9pPr>
   </p:defaultTextStyle>
+  <p:extLst>
+    <p:ext uri="{EFAFB233-063F-42B5-8137-9DF3F51BA10A}">
+      <p15:sldGuideLst xmlns:p15="http://schemas.microsoft.com/office/powerpoint/2012/main"/>
+    </p:ext>
+  </p:extLst>
 </p:presentation>
 </file>
 
@@ -381,7 +388,7 @@
           <a:p>
             <a:fld id="{5780CB7E-C8C7-4838-B73E-B57FD4D5BE91}" type="datetimeFigureOut">
               <a:rPr lang="en-US" smtClean="0"/>
-              <a:t>1/31/2026</a:t>
+              <a:t>2/1/2026</a:t>
             </a:fld>
             <a:endParaRPr lang="en-US"/>
           </a:p>
@@ -795,7 +802,7 @@
           <a:p>
             <a:fld id="{5780CB7E-C8C7-4838-B73E-B57FD4D5BE91}" type="datetimeFigureOut">
               <a:rPr lang="en-US" smtClean="0"/>
-              <a:t>1/31/2026</a:t>
+              <a:t>2/1/2026</a:t>
             </a:fld>
             <a:endParaRPr lang="en-US"/>
           </a:p>
@@ -1131,7 +1138,7 @@
           <a:p>
             <a:fld id="{5780CB7E-C8C7-4838-B73E-B57FD4D5BE91}" type="datetimeFigureOut">
               <a:rPr lang="en-US" smtClean="0"/>
-              <a:t>1/31/2026</a:t>
+              <a:t>2/1/2026</a:t>
             </a:fld>
             <a:endParaRPr lang="en-US"/>
           </a:p>
@@ -1536,7 +1543,7 @@
           <a:p>
             <a:fld id="{5780CB7E-C8C7-4838-B73E-B57FD4D5BE91}" type="datetimeFigureOut">
               <a:rPr lang="en-US" smtClean="0"/>
-              <a:t>1/31/2026</a:t>
+              <a:t>2/1/2026</a:t>
             </a:fld>
             <a:endParaRPr lang="en-US"/>
           </a:p>
@@ -2104,7 +2111,7 @@
           <a:p>
             <a:fld id="{5780CB7E-C8C7-4838-B73E-B57FD4D5BE91}" type="datetimeFigureOut">
               <a:rPr lang="en-US" smtClean="0"/>
-              <a:t>1/31/2026</a:t>
+              <a:t>2/1/2026</a:t>
             </a:fld>
             <a:endParaRPr lang="en-US"/>
           </a:p>
@@ -2785,7 +2792,7 @@
           <a:p>
             <a:fld id="{5780CB7E-C8C7-4838-B73E-B57FD4D5BE91}" type="datetimeFigureOut">
               <a:rPr lang="en-US" smtClean="0"/>
-              <a:t>1/31/2026</a:t>
+              <a:t>2/1/2026</a:t>
             </a:fld>
             <a:endParaRPr lang="en-US"/>
           </a:p>
@@ -3698,7 +3705,7 @@
           <a:p>
             <a:fld id="{5780CB7E-C8C7-4838-B73E-B57FD4D5BE91}" type="datetimeFigureOut">
               <a:rPr lang="en-US" smtClean="0"/>
-              <a:t>1/31/2026</a:t>
+              <a:t>2/1/2026</a:t>
             </a:fld>
             <a:endParaRPr lang="en-US"/>
           </a:p>
@@ -4011,7 +4018,7 @@
           <a:p>
             <a:fld id="{5780CB7E-C8C7-4838-B73E-B57FD4D5BE91}" type="datetimeFigureOut">
               <a:rPr lang="en-US" smtClean="0"/>
-              <a:t>1/31/2026</a:t>
+              <a:t>2/1/2026</a:t>
             </a:fld>
             <a:endParaRPr lang="en-US"/>
           </a:p>
@@ -4275,7 +4282,7 @@
           <a:p>
             <a:fld id="{5780CB7E-C8C7-4838-B73E-B57FD4D5BE91}" type="datetimeFigureOut">
               <a:rPr lang="en-US" smtClean="0"/>
-              <a:t>1/31/2026</a:t>
+              <a:t>2/1/2026</a:t>
             </a:fld>
             <a:endParaRPr lang="en-US"/>
           </a:p>
@@ -4598,7 +4605,7 @@
           <a:p>
             <a:fld id="{5780CB7E-C8C7-4838-B73E-B57FD4D5BE91}" type="datetimeFigureOut">
               <a:rPr lang="en-US" smtClean="0"/>
-              <a:t>1/31/2026</a:t>
+              <a:t>2/1/2026</a:t>
             </a:fld>
             <a:endParaRPr lang="en-US"/>
           </a:p>
@@ -4987,7 +4994,7 @@
           <a:p>
             <a:fld id="{5780CB7E-C8C7-4838-B73E-B57FD4D5BE91}" type="datetimeFigureOut">
               <a:rPr lang="en-US" smtClean="0"/>
-              <a:t>1/31/2026</a:t>
+              <a:t>2/1/2026</a:t>
             </a:fld>
             <a:endParaRPr lang="en-US"/>
           </a:p>
@@ -5363,7 +5370,7 @@
           <a:p>
             <a:fld id="{5780CB7E-C8C7-4838-B73E-B57FD4D5BE91}" type="datetimeFigureOut">
               <a:rPr lang="en-US" smtClean="0"/>
-              <a:t>1/31/2026</a:t>
+              <a:t>2/1/2026</a:t>
             </a:fld>
             <a:endParaRPr lang="en-US"/>
           </a:p>
@@ -5541,6 +5548,13 @@
             <a:schemeClr val="lt1"/>
           </a:fontRef>
         </p:style>
+        <p:txBody>
+          <a:bodyPr/>
+          <a:lstStyle/>
+          <a:p>
+            <a:endParaRPr lang="en-US"/>
+          </a:p>
+        </p:txBody>
       </p:sp>
       <p:sp>
         <p:nvSpPr>
@@ -5579,6 +5593,13 @@
             <a:schemeClr val="lt1"/>
           </a:fontRef>
         </p:style>
+        <p:txBody>
+          <a:bodyPr/>
+          <a:lstStyle/>
+          <a:p>
+            <a:endParaRPr lang="en-US"/>
+          </a:p>
+        </p:txBody>
       </p:sp>
       <p:sp>
         <p:nvSpPr>
@@ -5869,7 +5890,7 @@
           <a:p>
             <a:fld id="{5780CB7E-C8C7-4838-B73E-B57FD4D5BE91}" type="datetimeFigureOut">
               <a:rPr lang="en-US" smtClean="0"/>
-              <a:t>1/31/2026</a:t>
+              <a:t>2/1/2026</a:t>
             </a:fld>
             <a:endParaRPr lang="en-US"/>
           </a:p>
@@ -6126,7 +6147,7 @@
           <a:p>
             <a:fld id="{5780CB7E-C8C7-4838-B73E-B57FD4D5BE91}" type="datetimeFigureOut">
               <a:rPr lang="en-US" smtClean="0"/>
-              <a:t>1/31/2026</a:t>
+              <a:t>2/1/2026</a:t>
             </a:fld>
             <a:endParaRPr lang="en-US"/>
           </a:p>
@@ -6289,7 +6310,7 @@
           <a:p>
             <a:fld id="{5780CB7E-C8C7-4838-B73E-B57FD4D5BE91}" type="datetimeFigureOut">
               <a:rPr lang="en-US" smtClean="0"/>
-              <a:t>1/31/2026</a:t>
+              <a:t>2/1/2026</a:t>
             </a:fld>
             <a:endParaRPr lang="en-US"/>
           </a:p>
@@ -6679,7 +6700,7 @@
           <a:p>
             <a:fld id="{5780CB7E-C8C7-4838-B73E-B57FD4D5BE91}" type="datetimeFigureOut">
               <a:rPr lang="en-US" smtClean="0"/>
-              <a:t>1/31/2026</a:t>
+              <a:t>2/1/2026</a:t>
             </a:fld>
             <a:endParaRPr lang="en-US"/>
           </a:p>
@@ -7088,7 +7109,7 @@
           <a:p>
             <a:fld id="{5780CB7E-C8C7-4838-B73E-B57FD4D5BE91}" type="datetimeFigureOut">
               <a:rPr lang="en-US" smtClean="0"/>
-              <a:t>1/31/2026</a:t>
+              <a:t>2/1/2026</a:t>
             </a:fld>
             <a:endParaRPr lang="en-US"/>
           </a:p>
@@ -7332,7 +7353,7 @@
           <a:p>
             <a:fld id="{5780CB7E-C8C7-4838-B73E-B57FD4D5BE91}" type="datetimeFigureOut">
               <a:rPr lang="en-US" smtClean="0"/>
-              <a:t>1/31/2026</a:t>
+              <a:t>2/1/2026</a:t>
             </a:fld>
             <a:endParaRPr lang="en-US"/>
           </a:p>
@@ -8190,18 +8211,735 @@
   <p:clrMapOvr>
     <a:masterClrMapping/>
   </p:clrMapOvr>
-  <mc:AlternateContent xmlns:mc="http://schemas.openxmlformats.org/markup-compatibility/2006">
-    <mc:Choice xmlns:p14="http://schemas.microsoft.com/office/powerpoint/2010/main" Requires="p14">
+  <mc:AlternateContent xmlns:mc="http://schemas.openxmlformats.org/markup-compatibility/2006" xmlns:p14="http://schemas.microsoft.com/office/powerpoint/2010/main">
+    <mc:Choice Requires="p14">
       <p:transition spd="slow">
         <p14:flash/>
       </p:transition>
     </mc:Choice>
-    <mc:Fallback>
+    <mc:Fallback xmlns="">
       <p:transition spd="slow">
         <p:fade/>
       </p:transition>
     </mc:Fallback>
   </mc:AlternateContent>
+</p:sld>
+</file>
+
+<file path=ppt/slides/slide2.xml><?xml version="1.0" encoding="utf-8"?>
+<p:sld xmlns:a="http://schemas.openxmlformats.org/drawingml/2006/main" xmlns:r="http://schemas.openxmlformats.org/officeDocument/2006/relationships" xmlns:p="http://schemas.openxmlformats.org/presentationml/2006/main">
+  <p:cSld>
+    <p:bg>
+      <p:bgPr>
+        <a:gradFill rotWithShape="1">
+          <a:gsLst>
+            <a:gs pos="0">
+              <a:schemeClr val="bg2">
+                <a:tint val="96000"/>
+                <a:shade val="100000"/>
+                <a:hueMod val="270000"/>
+                <a:satMod val="200000"/>
+                <a:lumMod val="128000"/>
+              </a:schemeClr>
+            </a:gs>
+            <a:gs pos="50000">
+              <a:schemeClr val="bg2">
+                <a:shade val="100000"/>
+                <a:hueMod val="100000"/>
+                <a:satMod val="110000"/>
+                <a:lumMod val="130000"/>
+              </a:schemeClr>
+            </a:gs>
+            <a:gs pos="100000">
+              <a:schemeClr val="bg2">
+                <a:shade val="78000"/>
+                <a:hueMod val="44000"/>
+                <a:satMod val="200000"/>
+                <a:lumMod val="69000"/>
+              </a:schemeClr>
+            </a:gs>
+          </a:gsLst>
+          <a:lin ang="2520000" scaled="0"/>
+        </a:gradFill>
+        <a:effectLst/>
+      </p:bgPr>
+    </p:bg>
+    <p:spTree>
+      <p:nvGrpSpPr>
+        <p:cNvPr id="1" name=""/>
+        <p:cNvGrpSpPr/>
+        <p:nvPr/>
+      </p:nvGrpSpPr>
+      <p:grpSpPr>
+        <a:xfrm>
+          <a:off x="0" y="0"/>
+          <a:ext cx="0" cy="0"/>
+          <a:chOff x="0" y="0"/>
+          <a:chExt cx="0" cy="0"/>
+        </a:xfrm>
+      </p:grpSpPr>
+      <p:sp useBgFill="1">
+        <p:nvSpPr>
+          <p:cNvPr id="24" name="Rectangle 23">
+            <a:extLst>
+              <a:ext uri="{FF2B5EF4-FFF2-40B4-BE49-F238E27FC236}">
+                <a16:creationId xmlns:a16="http://schemas.microsoft.com/office/drawing/2014/main" id="{C8221A89-FE35-4C46-8874-69154D2A8CCA}"/>
+              </a:ext>
+              <a:ext uri="{C183D7F6-B498-43B3-948B-1728B52AA6E4}">
+                <adec:decorative xmlns:adec="http://schemas.microsoft.com/office/drawing/2017/decorative" val="1"/>
+              </a:ext>
+            </a:extLst>
+          </p:cNvPr>
+          <p:cNvSpPr>
+            <a:spLocks noGrp="1" noRot="1" noChangeAspect="1" noMove="1" noResize="1" noEditPoints="1" noAdjustHandles="1" noChangeArrowheads="1" noChangeShapeType="1" noTextEdit="1"/>
+          </p:cNvSpPr>
+          <p:nvPr>
+            <p:extLst>
+              <p:ext uri="{386F3935-93C4-4BCD-93E2-E3B085C9AB24}">
+                <p16:designElem xmlns:p16="http://schemas.microsoft.com/office/powerpoint/2015/main" val="1"/>
+              </p:ext>
+            </p:extLst>
+          </p:nvPr>
+        </p:nvSpPr>
+        <p:spPr>
+          <a:xfrm>
+            <a:off x="0" y="-1"/>
+            <a:ext cx="12188824" cy="6858001"/>
+          </a:xfrm>
+          <a:prstGeom prst="rect">
+            <a:avLst/>
+          </a:prstGeom>
+          <a:ln>
+            <a:noFill/>
+          </a:ln>
+        </p:spPr>
+        <p:style>
+          <a:lnRef idx="2">
+            <a:schemeClr val="accent1">
+              <a:shade val="50000"/>
+            </a:schemeClr>
+          </a:lnRef>
+          <a:fillRef idx="1">
+            <a:schemeClr val="accent1"/>
+          </a:fillRef>
+          <a:effectRef idx="0">
+            <a:schemeClr val="accent1"/>
+          </a:effectRef>
+          <a:fontRef idx="minor">
+            <a:schemeClr val="lt1"/>
+          </a:fontRef>
+        </p:style>
+        <p:txBody>
+          <a:bodyPr rtlCol="0" anchor="ctr"/>
+          <a:lstStyle/>
+          <a:p>
+            <a:pPr algn="ctr"/>
+            <a:endParaRPr lang="en-US"/>
+          </a:p>
+        </p:txBody>
+      </p:sp>
+      <p:pic>
+        <p:nvPicPr>
+          <p:cNvPr id="25" name="Picture 24" descr="Low angle view of a modern building">
+            <a:extLst>
+              <a:ext uri="{FF2B5EF4-FFF2-40B4-BE49-F238E27FC236}">
+                <a16:creationId xmlns:a16="http://schemas.microsoft.com/office/drawing/2014/main" id="{C30C3901-BA63-B04B-C180-410C86AC0245}"/>
+              </a:ext>
+            </a:extLst>
+          </p:cNvPr>
+          <p:cNvPicPr>
+            <a:picLocks noChangeAspect="1"/>
+          </p:cNvPicPr>
+          <p:nvPr/>
+        </p:nvPicPr>
+        <p:blipFill>
+          <a:blip r:embed="rId2">
+            <a:duotone>
+              <a:schemeClr val="bg2">
+                <a:shade val="45000"/>
+                <a:satMod val="135000"/>
+              </a:schemeClr>
+              <a:prstClr val="white"/>
+            </a:duotone>
+            <a:alphaModFix amt="41000"/>
+          </a:blip>
+          <a:srcRect t="13610" b="5162"/>
+          <a:stretch>
+            <a:fillRect/>
+          </a:stretch>
+        </p:blipFill>
+        <p:spPr>
+          <a:xfrm>
+            <a:off x="-3176" y="10"/>
+            <a:ext cx="12192000" cy="6857991"/>
+          </a:xfrm>
+          <a:prstGeom prst="rect">
+            <a:avLst/>
+          </a:prstGeom>
+        </p:spPr>
+      </p:pic>
+      <p:sp>
+        <p:nvSpPr>
+          <p:cNvPr id="26" name="Rectangle 25">
+            <a:extLst>
+              <a:ext uri="{FF2B5EF4-FFF2-40B4-BE49-F238E27FC236}">
+                <a16:creationId xmlns:a16="http://schemas.microsoft.com/office/drawing/2014/main" id="{259ACC7A-6809-44E9-A594-85696A6C2BED}"/>
+              </a:ext>
+              <a:ext uri="{C183D7F6-B498-43B3-948B-1728B52AA6E4}">
+                <adec:decorative xmlns:adec="http://schemas.microsoft.com/office/drawing/2017/decorative" val="1"/>
+              </a:ext>
+            </a:extLst>
+          </p:cNvPr>
+          <p:cNvSpPr>
+            <a:spLocks noGrp="1" noRot="1" noChangeAspect="1" noMove="1" noResize="1" noEditPoints="1" noAdjustHandles="1" noChangeArrowheads="1" noChangeShapeType="1" noTextEdit="1"/>
+          </p:cNvSpPr>
+          <p:nvPr>
+            <p:extLst>
+              <p:ext uri="{386F3935-93C4-4BCD-93E2-E3B085C9AB24}">
+                <p16:designElem xmlns:p16="http://schemas.microsoft.com/office/powerpoint/2015/main" val="1"/>
+              </p:ext>
+            </p:extLst>
+          </p:nvPr>
+        </p:nvSpPr>
+        <p:spPr bwMode="grayWhite">
+          <a:xfrm>
+            <a:off x="0" y="4249541"/>
+            <a:ext cx="8968085" cy="1660332"/>
+          </a:xfrm>
+          <a:prstGeom prst="rect">
+            <a:avLst/>
+          </a:prstGeom>
+          <a:solidFill>
+            <a:schemeClr val="bg1">
+              <a:lumMod val="95000"/>
+              <a:lumOff val="5000"/>
+              <a:alpha val="90000"/>
+            </a:schemeClr>
+          </a:solidFill>
+          <a:ln>
+            <a:noFill/>
+          </a:ln>
+        </p:spPr>
+        <p:style>
+          <a:lnRef idx="2">
+            <a:schemeClr val="accent1">
+              <a:shade val="50000"/>
+            </a:schemeClr>
+          </a:lnRef>
+          <a:fillRef idx="1">
+            <a:schemeClr val="accent1"/>
+          </a:fillRef>
+          <a:effectRef idx="0">
+            <a:schemeClr val="accent1"/>
+          </a:effectRef>
+          <a:fontRef idx="minor">
+            <a:schemeClr val="lt1"/>
+          </a:fontRef>
+        </p:style>
+        <p:txBody>
+          <a:bodyPr/>
+          <a:lstStyle/>
+          <a:p>
+            <a:endParaRPr lang="en-US"/>
+          </a:p>
+        </p:txBody>
+      </p:sp>
+      <p:sp>
+        <p:nvSpPr>
+          <p:cNvPr id="2" name="Title 1">
+            <a:extLst>
+              <a:ext uri="{FF2B5EF4-FFF2-40B4-BE49-F238E27FC236}">
+                <a16:creationId xmlns:a16="http://schemas.microsoft.com/office/drawing/2014/main" id="{7B8DF778-D6A3-2D69-EA5A-FF605C202FE9}"/>
+              </a:ext>
+            </a:extLst>
+          </p:cNvPr>
+          <p:cNvSpPr>
+            <a:spLocks noGrp="1"/>
+          </p:cNvSpPr>
+          <p:nvPr>
+            <p:ph type="ctrTitle"/>
+          </p:nvPr>
+        </p:nvSpPr>
+        <p:spPr>
+          <a:xfrm>
+            <a:off x="680322" y="4402667"/>
+            <a:ext cx="8133478" cy="940240"/>
+          </a:xfrm>
+        </p:spPr>
+        <p:txBody>
+          <a:bodyPr>
+            <a:normAutofit/>
+          </a:bodyPr>
+          <a:lstStyle/>
+          <a:p>
+            <a:r>
+              <a:rPr lang="en-US" sz="3000"/>
+              <a:t>Kiến trúc 3 lớp (3-Tier Architecture)</a:t>
+            </a:r>
+          </a:p>
+        </p:txBody>
+      </p:sp>
+      <p:sp>
+        <p:nvSpPr>
+          <p:cNvPr id="9" name="Subtitle 8">
+            <a:extLst>
+              <a:ext uri="{FF2B5EF4-FFF2-40B4-BE49-F238E27FC236}">
+                <a16:creationId xmlns:a16="http://schemas.microsoft.com/office/drawing/2014/main" id="{5AA59A61-AC2E-2BE8-D1B0-F4DEC08A87B0}"/>
+              </a:ext>
+            </a:extLst>
+          </p:cNvPr>
+          <p:cNvSpPr>
+            <a:spLocks noGrp="1"/>
+          </p:cNvSpPr>
+          <p:nvPr>
+            <p:ph type="subTitle" idx="1"/>
+          </p:nvPr>
+        </p:nvSpPr>
+        <p:spPr>
+          <a:xfrm>
+            <a:off x="680322" y="5342302"/>
+            <a:ext cx="8133478" cy="406566"/>
+          </a:xfrm>
+        </p:spPr>
+        <p:txBody>
+          <a:bodyPr>
+            <a:normAutofit/>
+          </a:bodyPr>
+          <a:lstStyle/>
+          <a:p>
+            <a:r>
+              <a:rPr lang="en-US" sz="1800"/>
+              <a:t>Tổng quan &amp; Mục tiêu</a:t>
+            </a:r>
+          </a:p>
+        </p:txBody>
+      </p:sp>
+      <p:sp>
+        <p:nvSpPr>
+          <p:cNvPr id="27" name="Rectangle 26">
+            <a:extLst>
+              <a:ext uri="{FF2B5EF4-FFF2-40B4-BE49-F238E27FC236}">
+                <a16:creationId xmlns:a16="http://schemas.microsoft.com/office/drawing/2014/main" id="{79E62B6A-C5F9-4D52-9F66-8777358274F9}"/>
+              </a:ext>
+              <a:ext uri="{C183D7F6-B498-43B3-948B-1728B52AA6E4}">
+                <adec:decorative xmlns:adec="http://schemas.microsoft.com/office/drawing/2017/decorative" val="1"/>
+              </a:ext>
+            </a:extLst>
+          </p:cNvPr>
+          <p:cNvSpPr>
+            <a:spLocks noGrp="1" noRot="1" noChangeAspect="1" noMove="1" noResize="1" noEditPoints="1" noAdjustHandles="1" noChangeArrowheads="1" noChangeShapeType="1" noTextEdit="1"/>
+          </p:cNvSpPr>
+          <p:nvPr>
+            <p:extLst>
+              <p:ext uri="{386F3935-93C4-4BCD-93E2-E3B085C9AB24}">
+                <p16:designElem xmlns:p16="http://schemas.microsoft.com/office/powerpoint/2015/main" val="1"/>
+              </p:ext>
+            </p:extLst>
+          </p:nvPr>
+        </p:nvSpPr>
+        <p:spPr>
+          <a:xfrm>
+            <a:off x="9111715" y="4249541"/>
+            <a:ext cx="3077109" cy="1660332"/>
+          </a:xfrm>
+          <a:prstGeom prst="rect">
+            <a:avLst/>
+          </a:prstGeom>
+          <a:solidFill>
+            <a:schemeClr val="accent1"/>
+          </a:solidFill>
+          <a:ln>
+            <a:noFill/>
+          </a:ln>
+        </p:spPr>
+        <p:style>
+          <a:lnRef idx="2">
+            <a:schemeClr val="accent1">
+              <a:shade val="50000"/>
+            </a:schemeClr>
+          </a:lnRef>
+          <a:fillRef idx="1">
+            <a:schemeClr val="accent1"/>
+          </a:fillRef>
+          <a:effectRef idx="0">
+            <a:schemeClr val="accent1"/>
+          </a:effectRef>
+          <a:fontRef idx="minor">
+            <a:schemeClr val="lt1"/>
+          </a:fontRef>
+        </p:style>
+        <p:txBody>
+          <a:bodyPr/>
+          <a:lstStyle/>
+          <a:p>
+            <a:endParaRPr lang="en-US"/>
+          </a:p>
+        </p:txBody>
+      </p:sp>
+      <p:sp>
+        <p:nvSpPr>
+          <p:cNvPr id="28" name="Rectangle 27">
+            <a:extLst>
+              <a:ext uri="{FF2B5EF4-FFF2-40B4-BE49-F238E27FC236}">
+                <a16:creationId xmlns:a16="http://schemas.microsoft.com/office/drawing/2014/main" id="{95F95C49-E748-4D32-8417-22E5B6A6F5E1}"/>
+              </a:ext>
+              <a:ext uri="{C183D7F6-B498-43B3-948B-1728B52AA6E4}">
+                <adec:decorative xmlns:adec="http://schemas.microsoft.com/office/drawing/2017/decorative" val="1"/>
+              </a:ext>
+            </a:extLst>
+          </p:cNvPr>
+          <p:cNvSpPr>
+            <a:spLocks noGrp="1" noRot="1" noChangeAspect="1" noMove="1" noResize="1" noEditPoints="1" noAdjustHandles="1" noChangeArrowheads="1" noChangeShapeType="1" noTextEdit="1"/>
+          </p:cNvSpPr>
+          <p:nvPr>
+            <p:extLst>
+              <p:ext uri="{386F3935-93C4-4BCD-93E2-E3B085C9AB24}">
+                <p16:designElem xmlns:p16="http://schemas.microsoft.com/office/powerpoint/2015/main" val="1"/>
+              </p:ext>
+            </p:extLst>
+          </p:nvPr>
+        </p:nvSpPr>
+        <p:spPr>
+          <a:xfrm>
+            <a:off x="0" y="5902314"/>
+            <a:ext cx="8968085" cy="275942"/>
+          </a:xfrm>
+          <a:prstGeom prst="rect">
+            <a:avLst/>
+          </a:prstGeom>
+          <a:blipFill>
+            <a:blip r:embed="rId3"/>
+            <a:stretch>
+              <a:fillRect/>
+            </a:stretch>
+          </a:blipFill>
+          <a:ln>
+            <a:noFill/>
+          </a:ln>
+        </p:spPr>
+        <p:style>
+          <a:lnRef idx="2">
+            <a:schemeClr val="accent1">
+              <a:shade val="50000"/>
+            </a:schemeClr>
+          </a:lnRef>
+          <a:fillRef idx="1">
+            <a:schemeClr val="accent1"/>
+          </a:fillRef>
+          <a:effectRef idx="0">
+            <a:schemeClr val="accent1"/>
+          </a:effectRef>
+          <a:fontRef idx="minor">
+            <a:schemeClr val="lt1"/>
+          </a:fontRef>
+        </p:style>
+        <p:txBody>
+          <a:bodyPr rtlCol="0" anchor="ctr"/>
+          <a:lstStyle/>
+          <a:p>
+            <a:pPr algn="ctr"/>
+            <a:endParaRPr lang="en-US"/>
+          </a:p>
+        </p:txBody>
+      </p:sp>
+      <p:sp>
+        <p:nvSpPr>
+          <p:cNvPr id="23" name="Rectangle 22">
+            <a:extLst>
+              <a:ext uri="{FF2B5EF4-FFF2-40B4-BE49-F238E27FC236}">
+                <a16:creationId xmlns:a16="http://schemas.microsoft.com/office/drawing/2014/main" id="{E2AE10EC-5E3B-4FC0-B43F-1E44500096E5}"/>
+              </a:ext>
+              <a:ext uri="{C183D7F6-B498-43B3-948B-1728B52AA6E4}">
+                <adec:decorative xmlns:adec="http://schemas.microsoft.com/office/drawing/2017/decorative" val="1"/>
+              </a:ext>
+            </a:extLst>
+          </p:cNvPr>
+          <p:cNvSpPr>
+            <a:spLocks noGrp="1" noRot="1" noChangeAspect="1" noMove="1" noResize="1" noEditPoints="1" noAdjustHandles="1" noChangeArrowheads="1" noChangeShapeType="1" noTextEdit="1"/>
+          </p:cNvSpPr>
+          <p:nvPr>
+            <p:extLst>
+              <p:ext uri="{386F3935-93C4-4BCD-93E2-E3B085C9AB24}">
+                <p16:designElem xmlns:p16="http://schemas.microsoft.com/office/powerpoint/2015/main" val="1"/>
+              </p:ext>
+            </p:extLst>
+          </p:nvPr>
+        </p:nvSpPr>
+        <p:spPr>
+          <a:xfrm>
+            <a:off x="9111715" y="5902314"/>
+            <a:ext cx="3080285" cy="275942"/>
+          </a:xfrm>
+          <a:prstGeom prst="rect">
+            <a:avLst/>
+          </a:prstGeom>
+          <a:blipFill>
+            <a:blip r:embed="rId4"/>
+            <a:stretch>
+              <a:fillRect/>
+            </a:stretch>
+          </a:blipFill>
+          <a:ln>
+            <a:noFill/>
+          </a:ln>
+        </p:spPr>
+        <p:style>
+          <a:lnRef idx="2">
+            <a:schemeClr val="accent1">
+              <a:shade val="50000"/>
+            </a:schemeClr>
+          </a:lnRef>
+          <a:fillRef idx="1">
+            <a:schemeClr val="accent1"/>
+          </a:fillRef>
+          <a:effectRef idx="0">
+            <a:schemeClr val="accent1"/>
+          </a:effectRef>
+          <a:fontRef idx="minor">
+            <a:schemeClr val="lt1"/>
+          </a:fontRef>
+        </p:style>
+        <p:txBody>
+          <a:bodyPr rtlCol="0" anchor="ctr"/>
+          <a:lstStyle/>
+          <a:p>
+            <a:pPr algn="ctr"/>
+            <a:endParaRPr lang="en-US"/>
+          </a:p>
+        </p:txBody>
+      </p:sp>
+    </p:spTree>
+    <p:extLst>
+      <p:ext uri="{BB962C8B-B14F-4D97-AF65-F5344CB8AC3E}">
+        <p14:creationId xmlns:p14="http://schemas.microsoft.com/office/powerpoint/2010/main" val="843863643"/>
+      </p:ext>
+    </p:extLst>
+  </p:cSld>
+  <p:clrMapOvr>
+    <a:masterClrMapping/>
+  </p:clrMapOvr>
+  <p:timing>
+    <p:tnLst>
+      <p:par>
+        <p:cTn id="1" dur="indefinite" restart="never" nodeType="tmRoot">
+          <p:childTnLst>
+            <p:seq concurrent="1" nextAc="seek">
+              <p:cTn id="2" dur="indefinite" nodeType="mainSeq">
+                <p:childTnLst>
+                  <p:par>
+                    <p:cTn id="3" fill="hold">
+                      <p:stCondLst>
+                        <p:cond delay="indefinite"/>
+                        <p:cond evt="onBegin" delay="0">
+                          <p:tn val="2"/>
+                        </p:cond>
+                      </p:stCondLst>
+                      <p:childTnLst>
+                        <p:par>
+                          <p:cTn id="4" fill="hold">
+                            <p:stCondLst>
+                              <p:cond delay="0"/>
+                            </p:stCondLst>
+                            <p:childTnLst>
+                              <p:par>
+                                <p:cTn id="5" presetID="10" presetClass="entr" presetSubtype="0" fill="hold" grpId="0" nodeType="withEffect">
+                                  <p:stCondLst>
+                                    <p:cond delay="1000"/>
+                                  </p:stCondLst>
+                                  <p:iterate type="lt">
+                                    <p:tmPct val="10000"/>
+                                  </p:iterate>
+                                  <p:childTnLst>
+                                    <p:set>
+                                      <p:cBhvr>
+                                        <p:cTn id="6" dur="1" fill="hold">
+                                          <p:stCondLst>
+                                            <p:cond delay="0"/>
+                                          </p:stCondLst>
+                                        </p:cTn>
+                                        <p:tgtEl>
+                                          <p:spTgt spid="2"/>
+                                        </p:tgtEl>
+                                        <p:attrNameLst>
+                                          <p:attrName>style.visibility</p:attrName>
+                                        </p:attrNameLst>
+                                      </p:cBhvr>
+                                      <p:to>
+                                        <p:strVal val="visible"/>
+                                      </p:to>
+                                    </p:set>
+                                    <p:animEffect transition="in" filter="fade">
+                                      <p:cBhvr>
+                                        <p:cTn id="7" dur="400"/>
+                                        <p:tgtEl>
+                                          <p:spTgt spid="2"/>
+                                        </p:tgtEl>
+                                      </p:cBhvr>
+                                    </p:animEffect>
+                                  </p:childTnLst>
+                                </p:cTn>
+                              </p:par>
+                              <p:par>
+                                <p:cTn id="8" presetID="10" presetClass="entr" presetSubtype="0" fill="hold" grpId="0" nodeType="withEffect">
+                                  <p:stCondLst>
+                                    <p:cond delay="2000"/>
+                                  </p:stCondLst>
+                                  <p:iterate type="lt">
+                                    <p:tmPct val="10000"/>
+                                  </p:iterate>
+                                  <p:childTnLst>
+                                    <p:set>
+                                      <p:cBhvr>
+                                        <p:cTn id="9" dur="1" fill="hold">
+                                          <p:stCondLst>
+                                            <p:cond delay="0"/>
+                                          </p:stCondLst>
+                                        </p:cTn>
+                                        <p:tgtEl>
+                                          <p:spTgt spid="9">
+                                            <p:txEl>
+                                              <p:pRg st="0" end="0"/>
+                                            </p:txEl>
+                                          </p:spTgt>
+                                        </p:tgtEl>
+                                        <p:attrNameLst>
+                                          <p:attrName>style.visibility</p:attrName>
+                                        </p:attrNameLst>
+                                      </p:cBhvr>
+                                      <p:to>
+                                        <p:strVal val="visible"/>
+                                      </p:to>
+                                    </p:set>
+                                    <p:animEffect transition="in" filter="fade">
+                                      <p:cBhvr>
+                                        <p:cTn id="10" dur="400"/>
+                                        <p:tgtEl>
+                                          <p:spTgt spid="9">
+                                            <p:txEl>
+                                              <p:pRg st="0" end="0"/>
+                                            </p:txEl>
+                                          </p:spTgt>
+                                        </p:tgtEl>
+                                      </p:cBhvr>
+                                    </p:animEffect>
+                                  </p:childTnLst>
+                                </p:cTn>
+                              </p:par>
+                            </p:childTnLst>
+                          </p:cTn>
+                        </p:par>
+                      </p:childTnLst>
+                    </p:cTn>
+                  </p:par>
+                </p:childTnLst>
+              </p:cTn>
+              <p:prevCondLst>
+                <p:cond evt="onPrev" delay="0">
+                  <p:tgtEl>
+                    <p:sldTgt/>
+                  </p:tgtEl>
+                </p:cond>
+              </p:prevCondLst>
+              <p:nextCondLst>
+                <p:cond evt="onNext" delay="0">
+                  <p:tgtEl>
+                    <p:sldTgt/>
+                  </p:tgtEl>
+                </p:cond>
+              </p:nextCondLst>
+            </p:seq>
+          </p:childTnLst>
+        </p:cTn>
+      </p:par>
+    </p:tnLst>
+    <p:bldLst>
+      <p:bldP spid="2" grpId="0"/>
+      <p:bldP spid="9" grpId="0" build="p"/>
+    </p:bldLst>
+  </p:timing>
+</p:sld>
+</file>
+
+<file path=ppt/slides/slide3.xml><?xml version="1.0" encoding="utf-8"?>
+<p:sld xmlns:a="http://schemas.openxmlformats.org/drawingml/2006/main" xmlns:r="http://schemas.openxmlformats.org/officeDocument/2006/relationships" xmlns:p="http://schemas.openxmlformats.org/presentationml/2006/main">
+  <p:cSld>
+    <p:spTree>
+      <p:nvGrpSpPr>
+        <p:cNvPr id="1" name=""/>
+        <p:cNvGrpSpPr/>
+        <p:nvPr/>
+      </p:nvGrpSpPr>
+      <p:grpSpPr>
+        <a:xfrm>
+          <a:off x="0" y="0"/>
+          <a:ext cx="0" cy="0"/>
+          <a:chOff x="0" y="0"/>
+          <a:chExt cx="0" cy="0"/>
+        </a:xfrm>
+      </p:grpSpPr>
+      <p:sp>
+        <p:nvSpPr>
+          <p:cNvPr id="2" name="Title 1">
+            <a:extLst>
+              <a:ext uri="{FF2B5EF4-FFF2-40B4-BE49-F238E27FC236}">
+                <a16:creationId xmlns:a16="http://schemas.microsoft.com/office/drawing/2014/main" id="{E0456444-44CB-01E3-EF5D-7A29BB339811}"/>
+              </a:ext>
+            </a:extLst>
+          </p:cNvPr>
+          <p:cNvSpPr>
+            <a:spLocks noGrp="1"/>
+          </p:cNvSpPr>
+          <p:nvPr>
+            <p:ph type="title"/>
+          </p:nvPr>
+        </p:nvSpPr>
+        <p:spPr/>
+        <p:txBody>
+          <a:bodyPr/>
+          <a:lstStyle/>
+          <a:p>
+            <a:r>
+              <a:rPr lang="en-US" dirty="0"/>
+              <a:t>Spring Data JPA Repository</a:t>
+            </a:r>
+          </a:p>
+        </p:txBody>
+      </p:sp>
+      <p:sp>
+        <p:nvSpPr>
+          <p:cNvPr id="3" name="Content Placeholder 2">
+            <a:extLst>
+              <a:ext uri="{FF2B5EF4-FFF2-40B4-BE49-F238E27FC236}">
+                <a16:creationId xmlns:a16="http://schemas.microsoft.com/office/drawing/2014/main" id="{EE48EAE6-1E5C-48BC-E9AA-B776A2684735}"/>
+              </a:ext>
+            </a:extLst>
+          </p:cNvPr>
+          <p:cNvSpPr>
+            <a:spLocks noGrp="1"/>
+          </p:cNvSpPr>
+          <p:nvPr>
+            <p:ph idx="1"/>
+          </p:nvPr>
+        </p:nvSpPr>
+        <p:spPr/>
+        <p:txBody>
+          <a:bodyPr/>
+          <a:lstStyle/>
+          <a:p>
+            <a:endParaRPr lang="en-US" dirty="0"/>
+          </a:p>
+        </p:txBody>
+      </p:sp>
+    </p:spTree>
+    <p:extLst>
+      <p:ext uri="{BB962C8B-B14F-4D97-AF65-F5344CB8AC3E}">
+        <p14:creationId xmlns:p14="http://schemas.microsoft.com/office/powerpoint/2010/main" val="66503573"/>
+      </p:ext>
+    </p:extLst>
+  </p:cSld>
+  <p:clrMapOvr>
+    <a:masterClrMapping/>
+  </p:clrMapOvr>
 </p:sld>
 </file>
 

</xml_diff>